<commit_message>
1 TB Example added in ppt and readme
</commit_message>
<xml_diff>
--- a/docs/presentation.pptx
+++ b/docs/presentation.pptx
@@ -23,6 +23,7 @@
     <p:sldId id="271" r:id="rId22"/>
     <p:sldId id="272" r:id="rId23"/>
     <p:sldId id="273" r:id="rId24"/>
+    <p:sldId id="274" r:id="rId25"/>
   </p:sldIdLst>
   <p:sldSz cx="12191695" cy="6858000" type="screen4x3"/>
   <p:notesSz cx="6858000" cy="9144000"/>
@@ -4274,7 +4275,7 @@
                 </a:solidFill>
                 <a:latin typeface="Calibri"/>
               </a:rPr>
-              <a:t>•  Independent Run / Rerun and Stop controls, cancellable mid-run — same pattern as the main scan.</a:t>
+              <a:t>•  The discovered path's real on-disk usage is measured and flagged if unusually large.</a:t>
             </a:r>
           </a:p>
           <a:p>
@@ -4290,7 +4291,7 @@
                 </a:solidFill>
                 <a:latin typeface="Calibri"/>
               </a:rPr>
-              <a:t>•  The screenshot is a genuine finding from this machine, not a mock-up.</a:t>
+              <a:t>•  Independent Run / Rerun and Stop controls, cancellable mid-run — same pattern as the main scan.</a:t>
             </a:r>
           </a:p>
         </p:txBody>
@@ -4398,7 +4399,7 @@
                 </a:solidFill>
                 <a:latin typeface="Calibri"/>
               </a:rPr>
-              <a:t>Storage AI  ·  App Data Suggestions tab  ·  real result from a live run</a:t>
+              <a:t>Storage AI  ·  App Data Suggestions tab  ·  real classification/advice/severity logic</a:t>
             </a:r>
           </a:p>
         </p:txBody>
@@ -4495,7 +4496,7 @@
                 </a:solidFill>
                 <a:latin typeface="Calibri"/>
               </a:rPr>
-              <a:t>NOVELTY</a:t>
+              <a:t>APPLICATION DISCOVERY</a:t>
             </a:r>
           </a:p>
         </p:txBody>
@@ -4530,7 +4531,7 @@
                 </a:solidFill>
                 <a:latin typeface="Calibri"/>
               </a:rPr>
-              <a:t>What's actually new here — for the record</a:t>
+              <a:t>Worked example: a 1 TB MongoDB data directory</a:t>
             </a:r>
           </a:p>
         </p:txBody>
@@ -4563,13 +4564,13 @@
               </a:spcAft>
             </a:pPr>
             <a:r>
-              <a:rPr sz="1700">
+              <a:rPr sz="1800">
                 <a:solidFill>
                   <a:srgbClr val="1F2D4E"/>
                 </a:solidFill>
                 <a:latin typeface="Calibri"/>
               </a:rPr>
-              <a:t>•  None of the individual algorithms are new — hashing, random forest, K-means, linear regression, extractive QA are all textbook.</a:t>
+              <a:t>•  mongod is found running with --dbpath /var/lib/mongodb (tier 1, live process introspection).</a:t>
             </a:r>
           </a:p>
           <a:p>
@@ -4579,13 +4580,13 @@
               </a:spcAft>
             </a:pPr>
             <a:r>
-              <a:rPr sz="1700">
+              <a:rPr sz="1800">
                 <a:solidFill>
                   <a:srgbClr val="1F2D4E"/>
                 </a:solidFill>
                 <a:latin typeface="Calibri"/>
               </a:rPr>
-              <a:t>•  Reliability-ordered discovery, not LLM-first — cheapest/most certain signal tried first.</a:t>
+              <a:t>•  Classified via the curated table as MongoDB → generic advice: "Consider MongoDB's built-in log rotation..."</a:t>
             </a:r>
           </a:p>
           <a:p>
@@ -4595,13 +4596,13 @@
               </a:spcAft>
             </a:pPr>
             <a:r>
-              <a:rPr sz="1700">
+              <a:rPr sz="1800">
                 <a:solidFill>
                   <a:srgbClr val="1F2D4E"/>
                 </a:solidFill>
                 <a:latin typeface="Calibri"/>
               </a:rPr>
-              <a:t>•  A deterministic gate around every non-deterministic component — applied independently in 3 unrelated subsystems.</a:t>
+              <a:t>•  A real filesystem walk of that path measures its actual size — deferred until after every cheaper filter already passed, so it's not wasted on findings nobody will see.</a:t>
             </a:r>
           </a:p>
           <a:p>
@@ -4611,13 +4612,13 @@
               </a:spcAft>
             </a:pPr>
             <a:r>
-              <a:rPr sz="1700">
+              <a:rPr sz="1800">
                 <a:solidFill>
                   <a:srgbClr val="1F2D4E"/>
                 </a:solidFill>
                 <a:latin typeface="Calibri"/>
               </a:rPr>
-              <a:t>•  A single-app lookup reused unchanged as a whole-system inventory (zero new discovery logic).</a:t>
+              <a:t>•  1 TB crosses the 50 GB "critical" threshold → the row is flagged ❗, bold, colored, and sorted to the top, ahead of every other finding regardless of discovery confidence.</a:t>
             </a:r>
           </a:p>
           <a:p>
@@ -4627,13 +4628,13 @@
               </a:spcAft>
             </a:pPr>
             <a:r>
-              <a:rPr sz="1700">
+              <a:rPr sz="1800">
                 <a:solidFill>
                   <a:srgbClr val="1F2D4E"/>
                 </a:solidFill>
                 <a:latin typeface="Calibri"/>
               </a:rPr>
-              <a:t>•  On-demand provenance for every displayed total, not just ML outputs.</a:t>
+              <a:t>•  Previously the same finding would show identical advice whether it used 10 MB or 10 TB — the size check is what turns a generic tip into an actual priority.</a:t>
             </a:r>
           </a:p>
         </p:txBody>
@@ -4668,7 +4669,7 @@
                 </a:solidFill>
                 <a:latin typeface="Calibri"/>
               </a:rPr>
-              <a:t>Storage AI  ·  Novelty  ·  docs/METHODOLOGY.md Section 9</a:t>
+              <a:t>Storage AI  ·  Worked example  ·  LARGE_SIZE_BYTES = 5 GB, CRITICAL_SIZE_BYTES = 50 GB</a:t>
             </a:r>
           </a:p>
         </p:txBody>
@@ -4765,7 +4766,7 @@
                 </a:solidFill>
                 <a:latin typeface="Calibri"/>
               </a:rPr>
-              <a:t>HONESTY</a:t>
+              <a:t>NOVELTY</a:t>
             </a:r>
           </a:p>
         </p:txBody>
@@ -4800,7 +4801,7 @@
                 </a:solidFill>
                 <a:latin typeface="Calibri"/>
               </a:rPr>
-              <a:t>Known limitations</a:t>
+              <a:t>What's actually new here — for the record</a:t>
             </a:r>
           </a:p>
         </p:txBody>
@@ -4833,13 +4834,13 @@
               </a:spcAft>
             </a:pPr>
             <a:r>
-              <a:rPr sz="1800">
+              <a:rPr sz="1700">
                 <a:solidFill>
                   <a:srgbClr val="1F2D4E"/>
                 </a:solidFill>
                 <a:latin typeface="Calibri"/>
               </a:rPr>
-              <a:t>•  Duplicate detection is exact-match only — near-duplicates are out of scope.</a:t>
+              <a:t>•  None of the individual algorithms are new — hashing, random forest, K-means, linear regression, extractive QA are all textbook.</a:t>
             </a:r>
           </a:p>
           <a:p>
@@ -4849,13 +4850,13 @@
               </a:spcAft>
             </a:pPr>
             <a:r>
-              <a:rPr sz="1800">
+              <a:rPr sz="1700">
                 <a:solidFill>
                   <a:srgbClr val="1F2D4E"/>
                 </a:solidFill>
                 <a:latin typeface="Calibri"/>
               </a:rPr>
-              <a:t>•  Known-service labels are default-location hints, not verified facts — a custom install won't match.</a:t>
+              <a:t>•  Reliability-ordered discovery, not LLM-first — cheapest/most certain signal tried first.</a:t>
             </a:r>
           </a:p>
           <a:p>
@@ -4865,13 +4866,13 @@
               </a:spcAft>
             </a:pPr>
             <a:r>
-              <a:rPr sz="1800">
+              <a:rPr sz="1700">
                 <a:solidFill>
                   <a:srgbClr val="1F2D4E"/>
                 </a:solidFill>
                 <a:latin typeface="Calibri"/>
               </a:rPr>
-              <a:t>•  Without --enable-audit, activity attribution is file-ownership based, not per-operation.</a:t>
+              <a:t>•  A deterministic gate around every non-deterministic component — applied independently in 3 unrelated subsystems.</a:t>
             </a:r>
           </a:p>
           <a:p>
@@ -4881,13 +4882,13 @@
               </a:spcAft>
             </a:pPr>
             <a:r>
-              <a:rPr sz="1800">
+              <a:rPr sz="1700">
                 <a:solidFill>
                   <a:srgbClr val="1F2D4E"/>
                 </a:solidFill>
                 <a:latin typeface="Calibri"/>
               </a:rPr>
-              <a:t>•  The LLM tier's own confidence score is not trustworthy alone — verified, not assumed.</a:t>
+              <a:t>•  A single-app lookup reused unchanged as a whole-system inventory (zero new discovery logic).</a:t>
             </a:r>
           </a:p>
           <a:p>
@@ -4897,13 +4898,13 @@
               </a:spcAft>
             </a:pPr>
             <a:r>
-              <a:rPr sz="1800">
+              <a:rPr sz="1700">
                 <a:solidFill>
                   <a:srgbClr val="1F2D4E"/>
                 </a:solidFill>
                 <a:latin typeface="Calibri"/>
               </a:rPr>
-              <a:t>•  No feedback loop yet records a user's accept/reject decision on a suggestion.</a:t>
+              <a:t>•  On-demand provenance for every displayed total, not just ML outputs.</a:t>
             </a:r>
           </a:p>
         </p:txBody>
@@ -4938,7 +4939,7 @@
                 </a:solidFill>
                 <a:latin typeface="Calibri"/>
               </a:rPr>
-              <a:t>Storage AI  ·  Known limitations  ·  docs/METHODOLOGY.md</a:t>
+              <a:t>Storage AI  ·  Novelty  ·  docs/METHODOLOGY.md Section 9</a:t>
             </a:r>
           </a:p>
         </p:txBody>
@@ -5035,7 +5036,7 @@
                 </a:solidFill>
                 <a:latin typeface="Calibri"/>
               </a:rPr>
-              <a:t>VERIFICATION</a:t>
+              <a:t>HONESTY</a:t>
             </a:r>
           </a:p>
         </p:txBody>
@@ -5070,7 +5071,7 @@
                 </a:solidFill>
                 <a:latin typeface="Calibri"/>
               </a:rPr>
-              <a:t>Tested for real, not just implemented</a:t>
+              <a:t>Known limitations</a:t>
             </a:r>
           </a:p>
         </p:txBody>
@@ -5109,7 +5110,7 @@
                 </a:solidFill>
                 <a:latin typeface="Calibri"/>
               </a:rPr>
-              <a:t>•  215 automated tests — non-GUI logic, plus GUI logic exercised via offscreen Qt.</a:t>
+              <a:t>•  Duplicate detection is exact-match only — near-duplicates are out of scope.</a:t>
             </a:r>
           </a:p>
           <a:p>
@@ -5125,7 +5126,7 @@
                 </a:solidFill>
                 <a:latin typeface="Calibri"/>
               </a:rPr>
-              <a:t>•  Real subprocesses tested for /proc-based discovery — not mocked.</a:t>
+              <a:t>•  Known-service labels are default-location hints, not verified facts — a custom install won't match.</a:t>
             </a:r>
           </a:p>
           <a:p>
@@ -5141,7 +5142,7 @@
                 </a:solidFill>
                 <a:latin typeface="Calibri"/>
               </a:rPr>
-              <a:t>•  The LLM tier tested against the real model — its calibration bugs are permanent regression tests.</a:t>
+              <a:t>•  Without --enable-audit, activity attribution is file-ownership based, not per-operation.</a:t>
             </a:r>
           </a:p>
           <a:p>
@@ -5157,7 +5158,23 @@
                 </a:solidFill>
                 <a:latin typeface="Calibri"/>
               </a:rPr>
-              <a:t>•  Fully offline: no network calls at runtime, no GPU, no API keys, no external services.</a:t>
+              <a:t>•  The LLM tier's own confidence score is not trustworthy alone — verified, not assumed.</a:t>
+            </a:r>
+          </a:p>
+          <a:p>
+            <a:pPr>
+              <a:spcAft>
+                <a:spcPts val="1000"/>
+              </a:spcAft>
+            </a:pPr>
+            <a:r>
+              <a:rPr sz="1800">
+                <a:solidFill>
+                  <a:srgbClr val="1F2D4E"/>
+                </a:solidFill>
+                <a:latin typeface="Calibri"/>
+              </a:rPr>
+              <a:t>•  No feedback loop yet records a user's accept/reject decision on a suggestion.</a:t>
             </a:r>
           </a:p>
         </p:txBody>
@@ -5192,7 +5209,7 @@
                 </a:solidFill>
                 <a:latin typeface="Calibri"/>
               </a:rPr>
-              <a:t>Storage AI  ·  Verification</a:t>
+              <a:t>Storage AI  ·  Known limitations  ·  docs/METHODOLOGY.md</a:t>
             </a:r>
           </a:p>
         </p:txBody>
@@ -5289,7 +5306,7 @@
                 </a:solidFill>
                 <a:latin typeface="Calibri"/>
               </a:rPr>
-              <a:t>WHAT'S NEXT</a:t>
+              <a:t>VERIFICATION</a:t>
             </a:r>
           </a:p>
         </p:txBody>
@@ -5324,7 +5341,7 @@
                 </a:solidFill>
                 <a:latin typeface="Calibri"/>
               </a:rPr>
-              <a:t>Future work</a:t>
+              <a:t>Tested for real, not just implemented</a:t>
             </a:r>
           </a:p>
         </p:txBody>
@@ -5363,7 +5380,7 @@
                 </a:solidFill>
                 <a:latin typeface="Calibri"/>
               </a:rPr>
-              <a:t>•  Multi-folder &amp; scheduled scanning; incremental scanning for large, slow-changing trees.</a:t>
+              <a:t>•  215 automated tests — non-GUI logic, plus GUI logic exercised via offscreen Qt.</a:t>
             </a:r>
           </a:p>
           <a:p>
@@ -5379,7 +5396,7 @@
                 </a:solidFill>
                 <a:latin typeface="Calibri"/>
               </a:rPr>
-              <a:t>•  Detect and prefer an already-running local LLM (e.g. Ollama) instead of always bundling one.</a:t>
+              <a:t>•  Real subprocesses tested for /proc-based discovery — not mocked.</a:t>
             </a:r>
           </a:p>
           <a:p>
@@ -5395,7 +5412,7 @@
                 </a:solidFill>
                 <a:latin typeface="Calibri"/>
               </a:rPr>
-              <a:t>•  A feedback-loop table recording accept/reject on every suggestion — the prerequisite for personalization.</a:t>
+              <a:t>•  The LLM tier tested against the real model — its calibration bugs are permanent regression tests.</a:t>
             </a:r>
           </a:p>
           <a:p>
@@ -5411,7 +5428,7 @@
                 </a:solidFill>
                 <a:latin typeface="Calibri"/>
               </a:rPr>
-              <a:t>•  Multi-host aggregation — a fleet-wide storage inventory across several machines.</a:t>
+              <a:t>•  Fully offline: no network calls at runtime, no GPU, no API keys, no external services.</a:t>
             </a:r>
           </a:p>
         </p:txBody>
@@ -5446,7 +5463,7 @@
                 </a:solidFill>
                 <a:latin typeface="Calibri"/>
               </a:rPr>
-              <a:t>Storage AI  ·  Future work  ·  see future_plan.md</a:t>
+              <a:t>Storage AI  ·  Verification</a:t>
             </a:r>
           </a:p>
         </p:txBody>
@@ -5460,6 +5477,260 @@
 </file>
 
 <file path=ppt/slides/slide18.xml><?xml version="1.0" encoding="utf-8"?>
+<p:sld xmlns:a="http://schemas.openxmlformats.org/drawingml/2006/main" xmlns:p="http://schemas.openxmlformats.org/presentationml/2006/main" xmlns:r="http://schemas.openxmlformats.org/officeDocument/2006/relationships">
+  <p:cSld>
+    <p:spTree>
+      <p:nvGrpSpPr>
+        <p:cNvPr id="1" name=""/>
+        <p:cNvGrpSpPr/>
+        <p:nvPr/>
+      </p:nvGrpSpPr>
+      <p:grpSpPr/>
+      <p:sp>
+        <p:nvSpPr>
+          <p:cNvPr id="2" name="Rectangle 1"/>
+          <p:cNvSpPr/>
+          <p:nvPr/>
+        </p:nvSpPr>
+        <p:spPr>
+          <a:xfrm>
+            <a:off x="0" y="0"/>
+            <a:ext cx="12191695" cy="128016"/>
+          </a:xfrm>
+          <a:prstGeom prst="rect">
+            <a:avLst/>
+          </a:prstGeom>
+          <a:solidFill>
+            <a:srgbClr val="33538A"/>
+          </a:solidFill>
+          <a:ln>
+            <a:noFill/>
+          </a:ln>
+          <a:effectLst/>
+        </p:spPr>
+        <p:style>
+          <a:lnRef idx="1">
+            <a:schemeClr val="accent1"/>
+          </a:lnRef>
+          <a:fillRef idx="3">
+            <a:schemeClr val="accent1"/>
+          </a:fillRef>
+          <a:effectRef idx="2">
+            <a:schemeClr val="accent1"/>
+          </a:effectRef>
+          <a:fontRef idx="minor">
+            <a:schemeClr val="lt1"/>
+          </a:fontRef>
+        </p:style>
+        <p:txBody>
+          <a:bodyPr rtlCol="0" anchor="ctr"/>
+          <a:lstStyle/>
+          <a:p>
+            <a:pPr algn="ctr"/>
+          </a:p>
+        </p:txBody>
+      </p:sp>
+      <p:sp>
+        <p:nvSpPr>
+          <p:cNvPr id="3" name="TextBox 2"/>
+          <p:cNvSpPr txBox="1"/>
+          <p:nvPr/>
+        </p:nvSpPr>
+        <p:spPr>
+          <a:xfrm>
+            <a:off x="548640" y="320040"/>
+            <a:ext cx="11094415" cy="365760"/>
+          </a:xfrm>
+          <a:prstGeom prst="rect">
+            <a:avLst/>
+          </a:prstGeom>
+          <a:noFill/>
+        </p:spPr>
+        <p:txBody>
+          <a:bodyPr wrap="square" anchor="t">
+            <a:spAutoFit/>
+          </a:bodyPr>
+          <a:lstStyle/>
+          <a:p>
+            <a:pPr algn="l"/>
+            <a:r>
+              <a:rPr sz="1400" b="1" i="0">
+                <a:solidFill>
+                  <a:srgbClr val="33538A"/>
+                </a:solidFill>
+                <a:latin typeface="Calibri"/>
+              </a:rPr>
+              <a:t>WHAT'S NEXT</a:t>
+            </a:r>
+          </a:p>
+        </p:txBody>
+      </p:sp>
+      <p:sp>
+        <p:nvSpPr>
+          <p:cNvPr id="4" name="TextBox 3"/>
+          <p:cNvSpPr txBox="1"/>
+          <p:nvPr/>
+        </p:nvSpPr>
+        <p:spPr>
+          <a:xfrm>
+            <a:off x="548640" y="658368"/>
+            <a:ext cx="11094415" cy="640080"/>
+          </a:xfrm>
+          <a:prstGeom prst="rect">
+            <a:avLst/>
+          </a:prstGeom>
+          <a:noFill/>
+        </p:spPr>
+        <p:txBody>
+          <a:bodyPr wrap="square" anchor="t">
+            <a:spAutoFit/>
+          </a:bodyPr>
+          <a:lstStyle/>
+          <a:p>
+            <a:pPr algn="l"/>
+            <a:r>
+              <a:rPr sz="3000" b="1" i="0">
+                <a:solidFill>
+                  <a:srgbClr val="1F2D4E"/>
+                </a:solidFill>
+                <a:latin typeface="Calibri"/>
+              </a:rPr>
+              <a:t>Future work</a:t>
+            </a:r>
+          </a:p>
+        </p:txBody>
+      </p:sp>
+      <p:sp>
+        <p:nvSpPr>
+          <p:cNvPr id="5" name="TextBox 4"/>
+          <p:cNvSpPr txBox="1"/>
+          <p:nvPr/>
+        </p:nvSpPr>
+        <p:spPr>
+          <a:xfrm>
+            <a:off x="548640" y="1481328"/>
+            <a:ext cx="11094415" cy="4736592"/>
+          </a:xfrm>
+          <a:prstGeom prst="rect">
+            <a:avLst/>
+          </a:prstGeom>
+          <a:noFill/>
+        </p:spPr>
+        <p:txBody>
+          <a:bodyPr wrap="square">
+            <a:spAutoFit/>
+          </a:bodyPr>
+          <a:lstStyle/>
+          <a:p>
+            <a:pPr>
+              <a:spcAft>
+                <a:spcPts val="1000"/>
+              </a:spcAft>
+            </a:pPr>
+            <a:r>
+              <a:rPr sz="1800">
+                <a:solidFill>
+                  <a:srgbClr val="1F2D4E"/>
+                </a:solidFill>
+                <a:latin typeface="Calibri"/>
+              </a:rPr>
+              <a:t>•  Multi-folder &amp; scheduled scanning; incremental scanning for large, slow-changing trees.</a:t>
+            </a:r>
+          </a:p>
+          <a:p>
+            <a:pPr>
+              <a:spcAft>
+                <a:spcPts val="1000"/>
+              </a:spcAft>
+            </a:pPr>
+            <a:r>
+              <a:rPr sz="1800">
+                <a:solidFill>
+                  <a:srgbClr val="1F2D4E"/>
+                </a:solidFill>
+                <a:latin typeface="Calibri"/>
+              </a:rPr>
+              <a:t>•  Detect and prefer an already-running local LLM (e.g. Ollama) instead of always bundling one.</a:t>
+            </a:r>
+          </a:p>
+          <a:p>
+            <a:pPr>
+              <a:spcAft>
+                <a:spcPts val="1000"/>
+              </a:spcAft>
+            </a:pPr>
+            <a:r>
+              <a:rPr sz="1800">
+                <a:solidFill>
+                  <a:srgbClr val="1F2D4E"/>
+                </a:solidFill>
+                <a:latin typeface="Calibri"/>
+              </a:rPr>
+              <a:t>•  A feedback-loop table recording accept/reject on every suggestion — the prerequisite for personalization.</a:t>
+            </a:r>
+          </a:p>
+          <a:p>
+            <a:pPr>
+              <a:spcAft>
+                <a:spcPts val="1000"/>
+              </a:spcAft>
+            </a:pPr>
+            <a:r>
+              <a:rPr sz="1800">
+                <a:solidFill>
+                  <a:srgbClr val="1F2D4E"/>
+                </a:solidFill>
+                <a:latin typeface="Calibri"/>
+              </a:rPr>
+              <a:t>•  Multi-host aggregation — a fleet-wide storage inventory across several machines.</a:t>
+            </a:r>
+          </a:p>
+        </p:txBody>
+      </p:sp>
+      <p:sp>
+        <p:nvSpPr>
+          <p:cNvPr id="6" name="TextBox 5"/>
+          <p:cNvSpPr txBox="1"/>
+          <p:nvPr/>
+        </p:nvSpPr>
+        <p:spPr>
+          <a:xfrm>
+            <a:off x="548640" y="6400800"/>
+            <a:ext cx="11094415" cy="320040"/>
+          </a:xfrm>
+          <a:prstGeom prst="rect">
+            <a:avLst/>
+          </a:prstGeom>
+          <a:noFill/>
+        </p:spPr>
+        <p:txBody>
+          <a:bodyPr wrap="square" anchor="t">
+            <a:spAutoFit/>
+          </a:bodyPr>
+          <a:lstStyle/>
+          <a:p>
+            <a:pPr algn="l"/>
+            <a:r>
+              <a:rPr sz="1100" b="0" i="1">
+                <a:solidFill>
+                  <a:srgbClr val="555F70"/>
+                </a:solidFill>
+                <a:latin typeface="Calibri"/>
+              </a:rPr>
+              <a:t>Storage AI  ·  Future work  ·  see future_plan.md</a:t>
+            </a:r>
+          </a:p>
+        </p:txBody>
+      </p:sp>
+    </p:spTree>
+  </p:cSld>
+  <p:clrMapOvr>
+    <a:masterClrMapping/>
+  </p:clrMapOvr>
+</p:sld>
+</file>
+
+<file path=ppt/slides/slide19.xml><?xml version="1.0" encoding="utf-8"?>
 <p:sld xmlns:a="http://schemas.openxmlformats.org/drawingml/2006/main" xmlns:p="http://schemas.openxmlformats.org/presentationml/2006/main" xmlns:r="http://schemas.openxmlformats.org/officeDocument/2006/relationships">
   <p:cSld>
     <p:spTree>

</xml_diff>